<commit_message>
feat: update bid PPT with CDP chapter, path sampling, and refined descriptions (de-uhv)
</commit_message>
<xml_diff>
--- a/红创科技仿真平台_投标讲稿.pptx
+++ b/红创科技仿真平台_投标讲稿.pptx
@@ -11,8 +11,6 @@
     <p:sldId id="259" r:id="rId10"/>
     <p:sldId id="260" r:id="rId11"/>
     <p:sldId id="261" r:id="rId12"/>
-    <p:sldId id="262" r:id="rId13"/>
-    <p:sldId id="263" r:id="rId14"/>
   </p:sldIdLst>
   <p:sldSz cx="12191695" cy="6858000" type="screen4x3"/>
   <p:notesSz cx="6858000" cy="9144000"/>
@@ -3161,14 +3159,49 @@
           <a:lstStyle/>
           <a:p>
             <a:pPr algn="ctr">
-              <a:defRPr sz="2200">
+              <a:defRPr sz="2400">
                 <a:solidFill>
                   <a:srgbClr val="FFFFFF"/>
                 </a:solidFill>
               </a:defRPr>
             </a:pPr>
             <a:r>
-              <a:t>仿真动画演示 — 投标技术讲稿  |  2026年5月</a:t>
+              <a:t>仿真动画演示 — 投标技术讲稿</a:t>
+            </a:r>
+          </a:p>
+        </p:txBody>
+      </p:sp>
+      <p:sp>
+        <p:nvSpPr>
+          <p:cNvPr id="4" name="TextBox 3"/>
+          <p:cNvSpPr txBox="1"/>
+          <p:nvPr/>
+        </p:nvSpPr>
+        <p:spPr>
+          <a:xfrm>
+            <a:off x="914400" y="3657600"/>
+            <a:ext cx="10058400" cy="457200"/>
+          </a:xfrm>
+          <a:prstGeom prst="rect">
+            <a:avLst/>
+          </a:prstGeom>
+          <a:noFill/>
+        </p:spPr>
+        <p:txBody>
+          <a:bodyPr wrap="none">
+            <a:spAutoFit/>
+          </a:bodyPr>
+          <a:lstStyle/>
+          <a:p>
+            <a:pPr algn="ctr">
+              <a:defRPr sz="1600">
+                <a:solidFill>
+                  <a:srgbClr val="888888"/>
+                </a:solidFill>
+              </a:defRPr>
+            </a:pPr>
+            <a:r>
+              <a:t>2026年5月</a:t>
             </a:r>
           </a:p>
         </p:txBody>
@@ -3216,7 +3249,7 @@
           <a:noFill/>
         </p:spPr>
         <p:txBody>
-          <a:bodyPr wrap="none">
+          <a:bodyPr wrap="square">
             <a:spAutoFit/>
           </a:bodyPr>
           <a:lstStyle/>
@@ -3229,7 +3262,7 @@
               </a:defRPr>
             </a:pPr>
             <a:r>
-              <a:t>1. 悬臂梁线弹性加载</a:t>
+              <a:t>Demo 1: 悬臂梁静力学 (Hex8 + B-bar + 集中力)</a:t>
             </a:r>
           </a:p>
         </p:txBody>
@@ -3264,7 +3297,7 @@
               </a:defRPr>
             </a:pPr>
             <a:r>
-              <a:t>350节点 985四面体 · 11载荷步 · 5000×变形</a:t>
+              <a:t>Hex8 六面体单元 · B-bar 体积锁定处理 · 集中载荷 · 3000× 变形放大 · 逐面着色</a:t>
             </a:r>
           </a:p>
         </p:txBody>
@@ -3295,7 +3328,7 @@
         <p:spPr>
           <a:xfrm>
             <a:off x="548640" y="1188720"/>
-            <a:ext cx="11064240" cy="5029200"/>
+            <a:ext cx="11064240" cy="5303520"/>
           </a:xfrm>
           <a:prstGeom prst="rect">
             <a:avLst/>
@@ -3367,7 +3400,7 @@
           <a:noFill/>
         </p:spPr>
         <p:txBody>
-          <a:bodyPr wrap="none">
+          <a:bodyPr wrap="square">
             <a:spAutoFit/>
           </a:bodyPr>
           <a:lstStyle/>
@@ -3380,7 +3413,7 @@
               </a:defRPr>
             </a:pPr>
             <a:r>
-              <a:t>2. 接触力学演化</a:t>
+              <a:t>Demo 2: 接触力学 (5s 真实 FEM 渲染)</a:t>
             </a:r>
           </a:p>
         </p:txBody>
@@ -3415,7 +3448,7 @@
               </a:defRPr>
             </a:pPr>
             <a:r>
-              <a:t>两体 Coulomb摩擦 · 右块逐渐压入 · 位移0→0.17mm</a:t>
+              <a:t>Lagrange 乘子法接触约束 · Coulomb 摩擦 · 位移 0→0.17mm · 网格逐面着色 · 真实求解器渲染</a:t>
             </a:r>
           </a:p>
         </p:txBody>
@@ -3446,7 +3479,7 @@
         <p:spPr>
           <a:xfrm>
             <a:off x="548640" y="1188720"/>
-            <a:ext cx="11064240" cy="5029200"/>
+            <a:ext cx="11064240" cy="5303520"/>
           </a:xfrm>
           <a:prstGeom prst="rect">
             <a:avLst/>
@@ -3518,7 +3551,7 @@
           <a:noFill/>
         </p:spPr>
         <p:txBody>
-          <a:bodyPr wrap="none">
+          <a:bodyPr wrap="square">
             <a:spAutoFit/>
           </a:bodyPr>
           <a:lstStyle/>
@@ -3531,7 +3564,7 @@
               </a:defRPr>
             </a:pPr>
             <a:r>
-              <a:t>3. 静电双材料电位场</a:t>
+              <a:t>Demo 3: 双材料静电场</a:t>
             </a:r>
           </a:p>
         </p:txBody>
@@ -3566,7 +3599,7 @@
               </a:defRPr>
             </a:pPr>
             <a:r>
-              <a:t>钢(10⁷S/m) + 混凝土(10⁻²S/m) · 电位梯度</a:t>
+              <a:t>钢(σ=10⁷ S/m) + 混凝土(σ=10⁻² S/m) · 电位 0→1V 渐进 · 3D 挤出网格</a:t>
             </a:r>
           </a:p>
         </p:txBody>
@@ -3596,8 +3629,76 @@
         </p:blipFill>
         <p:spPr>
           <a:xfrm>
-            <a:off x="548640" y="1188720"/>
-            <a:ext cx="11064240" cy="5029200"/>
+            <a:off x="274320" y="1188720"/>
+            <a:ext cx="8686800" cy="5303520"/>
+          </a:xfrm>
+          <a:prstGeom prst="rect">
+            <a:avLst/>
+          </a:prstGeom>
+        </p:spPr>
+      </p:pic>
+      <p:sp>
+        <p:nvSpPr>
+          <p:cNvPr id="5" name="TextBox 4"/>
+          <p:cNvSpPr txBox="1"/>
+          <p:nvPr/>
+        </p:nvSpPr>
+        <p:spPr>
+          <a:xfrm>
+            <a:off x="9235440" y="1188720"/>
+            <a:ext cx="2743200" cy="365760"/>
+          </a:xfrm>
+          <a:prstGeom prst="rect">
+            <a:avLst/>
+          </a:prstGeom>
+          <a:noFill/>
+        </p:spPr>
+        <p:txBody>
+          <a:bodyPr wrap="none">
+            <a:spAutoFit/>
+          </a:bodyPr>
+          <a:lstStyle/>
+          <a:p>
+            <a:pPr algn="ctr">
+              <a:defRPr sz="1200">
+                <a:solidFill>
+                  <a:srgbClr val="D4AF37"/>
+                </a:solidFill>
+              </a:defRPr>
+            </a:pPr>
+            <a:r>
+              <a:t>路径采样</a:t>
+            </a:r>
+          </a:p>
+        </p:txBody>
+      </p:sp>
+      <p:pic>
+        <p:nvPicPr>
+          <p:cNvPr id="6" name="electrostatic_path.mp4">
+            <a:hlinkClick r:id="" action="ppaction://media"/>
+          </p:cNvPr>
+          <p:cNvPicPr>
+            <a:picLocks noChangeAspect="1"/>
+          </p:cNvPicPr>
+          <p:nvPr>
+            <a:videoFile r:link="rId6"/>
+            <p:extLst>
+              <p:ext uri="{DAA4B4D4-6D71-4841-9C94-3DE7FCFB9230}">
+                <p14:media xmlns:p14="http://schemas.microsoft.com/office/powerpoint/2010/main" r:embed="rId5"/>
+              </p:ext>
+            </p:extLst>
+          </p:nvPr>
+        </p:nvPicPr>
+        <p:blipFill>
+          <a:blip r:embed="rId4"/>
+          <a:stretch>
+            <a:fillRect/>
+          </a:stretch>
+        </p:blipFill>
+        <p:spPr>
+          <a:xfrm>
+            <a:off x="9235440" y="1645920"/>
+            <a:ext cx="2743200" cy="4846320"/>
           </a:xfrm>
           <a:prstGeom prst="rect">
             <a:avLst/>
@@ -3623,6 +3724,18 @@
                 </p:cTn>
                 <p:tgtEl>
                   <p:spTgt spid="4"/>
+                </p:tgtEl>
+              </p:cMediaNode>
+            </p:video>
+            <p:video>
+              <p:cMediaNode vol="80000">
+                <p:cTn id="3" fill="hold" display="0">
+                  <p:stCondLst>
+                    <p:cond delay="indefinite"/>
+                  </p:stCondLst>
+                </p:cTn>
+                <p:tgtEl>
+                  <p:spTgt spid="6"/>
                 </p:tgtEl>
               </p:cMediaNode>
             </p:video>
@@ -3669,7 +3782,7 @@
           <a:noFill/>
         </p:spPr>
         <p:txBody>
-          <a:bodyPr wrap="none">
+          <a:bodyPr wrap="square">
             <a:spAutoFit/>
           </a:bodyPr>
           <a:lstStyle/>
@@ -3682,7 +3795,7 @@
               </a:defRPr>
             </a:pPr>
             <a:r>
-              <a:t>4. 声学 Helmholtz 驻波</a:t>
+              <a:t>Demo 4: 热-力-损伤三场耦合 (CDP)</a:t>
             </a:r>
           </a:p>
         </p:txBody>
@@ -3717,14 +3830,14 @@
               </a:defRPr>
             </a:pPr>
             <a:r>
-              <a:t>861节点 800四边形 · |p|幅值 · 1000Hz</a:t>
+              <a:t>Concrete Damaged Plasticity · 温度-应力-损伤直接耦合 · 损伤变量演化 · 单求解器全隐式</a:t>
             </a:r>
           </a:p>
         </p:txBody>
       </p:sp>
       <p:pic>
         <p:nvPicPr>
-          <p:cNvPr id="4" name="acoustic.mp4">
+          <p:cNvPr id="4" name="cdp_damage.mp4">
             <a:hlinkClick r:id="" action="ppaction://media"/>
           </p:cNvPr>
           <p:cNvPicPr>
@@ -3748,7 +3861,7 @@
         <p:spPr>
           <a:xfrm>
             <a:off x="548640" y="1188720"/>
-            <a:ext cx="11064240" cy="5029200"/>
+            <a:ext cx="11064240" cy="5303520"/>
           </a:xfrm>
           <a:prstGeom prst="rect">
             <a:avLst/>
@@ -3811,309 +3924,7 @@
         </p:nvSpPr>
         <p:spPr>
           <a:xfrm>
-            <a:off x="457200" y="182880"/>
-            <a:ext cx="10972800" cy="640080"/>
-          </a:xfrm>
-          <a:prstGeom prst="rect">
-            <a:avLst/>
-          </a:prstGeom>
-          <a:noFill/>
-        </p:spPr>
-        <p:txBody>
-          <a:bodyPr wrap="none">
-            <a:spAutoFit/>
-          </a:bodyPr>
-          <a:lstStyle/>
-          <a:p>
-            <a:pPr>
-              <a:defRPr sz="3000" b="1">
-                <a:solidFill>
-                  <a:srgbClr val="C62828"/>
-                </a:solidFill>
-              </a:defRPr>
-            </a:pPr>
-            <a:r>
-              <a:t>5. 疲劳 S-N + Miner 损伤</a:t>
-            </a:r>
-          </a:p>
-        </p:txBody>
-      </p:sp>
-      <p:sp>
-        <p:nvSpPr>
-          <p:cNvPr id="3" name="TextBox 2"/>
-          <p:cNvSpPr txBox="1"/>
-          <p:nvPr/>
-        </p:nvSpPr>
-        <p:spPr>
-          <a:xfrm>
-            <a:off x="457200" y="777240"/>
-            <a:ext cx="10972800" cy="365760"/>
-          </a:xfrm>
-          <a:prstGeom prst="rect">
-            <a:avLst/>
-          </a:prstGeom>
-          <a:noFill/>
-        </p:spPr>
-        <p:txBody>
-          <a:bodyPr wrap="none">
-            <a:spAutoFit/>
-          </a:bodyPr>
-          <a:lstStyle/>
-          <a:p>
-            <a:pPr>
-              <a:defRPr sz="1400">
-                <a:solidFill>
-                  <a:srgbClr val="888888"/>
-                </a:solidFill>
-              </a:defRPr>
-            </a:pPr>
-            <a:r>
-              <a:t>雨流计数 + Miner规则 · 损伤累积分布</a:t>
-            </a:r>
-          </a:p>
-        </p:txBody>
-      </p:sp>
-      <p:pic>
-        <p:nvPicPr>
-          <p:cNvPr id="4" name="fatigue.mp4">
-            <a:hlinkClick r:id="" action="ppaction://media"/>
-          </p:cNvPr>
-          <p:cNvPicPr>
-            <a:picLocks noChangeAspect="1"/>
-          </p:cNvPicPr>
-          <p:nvPr>
-            <a:videoFile r:link="rId3"/>
-            <p:extLst>
-              <p:ext uri="{DAA4B4D4-6D71-4841-9C94-3DE7FCFB9230}">
-                <p14:media xmlns:p14="http://schemas.microsoft.com/office/powerpoint/2010/main" r:embed="rId2"/>
-              </p:ext>
-            </p:extLst>
-          </p:nvPr>
-        </p:nvPicPr>
-        <p:blipFill>
-          <a:blip r:embed="rId4"/>
-          <a:stretch>
-            <a:fillRect/>
-          </a:stretch>
-        </p:blipFill>
-        <p:spPr>
-          <a:xfrm>
-            <a:off x="548640" y="1188720"/>
-            <a:ext cx="11064240" cy="5029200"/>
-          </a:xfrm>
-          <a:prstGeom prst="rect">
-            <a:avLst/>
-          </a:prstGeom>
-        </p:spPr>
-      </p:pic>
-    </p:spTree>
-  </p:cSld>
-  <p:clrMapOvr>
-    <a:masterClrMapping/>
-  </p:clrMapOvr>
-  <p:timing>
-    <p:tnLst>
-      <p:par>
-        <p:cTn id="1" dur="indefinite" restart="never" nodeType="tmRoot">
-          <p:childTnLst>
-            <p:video>
-              <p:cMediaNode vol="80000">
-                <p:cTn id="2" fill="hold" display="0">
-                  <p:stCondLst>
-                    <p:cond delay="indefinite"/>
-                  </p:stCondLst>
-                </p:cTn>
-                <p:tgtEl>
-                  <p:spTgt spid="4"/>
-                </p:tgtEl>
-              </p:cMediaNode>
-            </p:video>
-          </p:childTnLst>
-        </p:cTn>
-      </p:par>
-    </p:tnLst>
-  </p:timing>
-</p:sld>
-</file>
-
-<file path=ppt/slides/slide7.xml><?xml version="1.0" encoding="utf-8"?>
-<p:sld xmlns:a="http://schemas.openxmlformats.org/drawingml/2006/main" xmlns:p="http://schemas.openxmlformats.org/presentationml/2006/main" xmlns:r="http://schemas.openxmlformats.org/officeDocument/2006/relationships">
-  <p:cSld>
-    <p:bg>
-      <p:bgPr>
-        <a:solidFill>
-          <a:srgbClr val="1A1A2E"/>
-        </a:solidFill>
-        <a:effectLst/>
-      </p:bgPr>
-    </p:bg>
-    <p:spTree>
-      <p:nvGrpSpPr>
-        <p:cNvPr id="1" name=""/>
-        <p:cNvGrpSpPr/>
-        <p:nvPr/>
-      </p:nvGrpSpPr>
-      <p:grpSpPr/>
-      <p:sp>
-        <p:nvSpPr>
-          <p:cNvPr id="2" name="TextBox 1"/>
-          <p:cNvSpPr txBox="1"/>
-          <p:nvPr/>
-        </p:nvSpPr>
-        <p:spPr>
-          <a:xfrm>
-            <a:off x="457200" y="182880"/>
-            <a:ext cx="10972800" cy="640080"/>
-          </a:xfrm>
-          <a:prstGeom prst="rect">
-            <a:avLst/>
-          </a:prstGeom>
-          <a:noFill/>
-        </p:spPr>
-        <p:txBody>
-          <a:bodyPr wrap="none">
-            <a:spAutoFit/>
-          </a:bodyPr>
-          <a:lstStyle/>
-          <a:p>
-            <a:pPr>
-              <a:defRPr sz="3000" b="1">
-                <a:solidFill>
-                  <a:srgbClr val="C62828"/>
-                </a:solidFill>
-              </a:defRPr>
-            </a:pPr>
-            <a:r>
-              <a:t>6. 多物理耦合 (热+力+损伤)</a:t>
-            </a:r>
-          </a:p>
-        </p:txBody>
-      </p:sp>
-      <p:sp>
-        <p:nvSpPr>
-          <p:cNvPr id="3" name="TextBox 2"/>
-          <p:cNvSpPr txBox="1"/>
-          <p:nvPr/>
-        </p:nvSpPr>
-        <p:spPr>
-          <a:xfrm>
-            <a:off x="457200" y="777240"/>
-            <a:ext cx="10972800" cy="365760"/>
-          </a:xfrm>
-          <a:prstGeom prst="rect">
-            <a:avLst/>
-          </a:prstGeom>
-          <a:noFill/>
-        </p:spPr>
-        <p:txBody>
-          <a:bodyPr wrap="none">
-            <a:spAutoFit/>
-          </a:bodyPr>
-          <a:lstStyle/>
-          <a:p>
-            <a:pPr>
-              <a:defRPr sz="1400">
-                <a:solidFill>
-                  <a:srgbClr val="888888"/>
-                </a:solidFill>
-              </a:defRPr>
-            </a:pPr>
-            <a:r>
-              <a:t>温度/位移/损伤三场轮播 · 直接耦合</a:t>
-            </a:r>
-          </a:p>
-        </p:txBody>
-      </p:sp>
-      <p:pic>
-        <p:nvPicPr>
-          <p:cNvPr id="4" name="multiphysics_coupling.mp4">
-            <a:hlinkClick r:id="" action="ppaction://media"/>
-          </p:cNvPr>
-          <p:cNvPicPr>
-            <a:picLocks noChangeAspect="1"/>
-          </p:cNvPicPr>
-          <p:nvPr>
-            <a:videoFile r:link="rId3"/>
-            <p:extLst>
-              <p:ext uri="{DAA4B4D4-6D71-4841-9C94-3DE7FCFB9230}">
-                <p14:media xmlns:p14="http://schemas.microsoft.com/office/powerpoint/2010/main" r:embed="rId2"/>
-              </p:ext>
-            </p:extLst>
-          </p:nvPr>
-        </p:nvPicPr>
-        <p:blipFill>
-          <a:blip r:embed="rId4"/>
-          <a:stretch>
-            <a:fillRect/>
-          </a:stretch>
-        </p:blipFill>
-        <p:spPr>
-          <a:xfrm>
-            <a:off x="548640" y="1188720"/>
-            <a:ext cx="11064240" cy="5029200"/>
-          </a:xfrm>
-          <a:prstGeom prst="rect">
-            <a:avLst/>
-          </a:prstGeom>
-        </p:spPr>
-      </p:pic>
-    </p:spTree>
-  </p:cSld>
-  <p:clrMapOvr>
-    <a:masterClrMapping/>
-  </p:clrMapOvr>
-  <p:timing>
-    <p:tnLst>
-      <p:par>
-        <p:cTn id="1" dur="indefinite" restart="never" nodeType="tmRoot">
-          <p:childTnLst>
-            <p:video>
-              <p:cMediaNode vol="80000">
-                <p:cTn id="2" fill="hold" display="0">
-                  <p:stCondLst>
-                    <p:cond delay="indefinite"/>
-                  </p:stCondLst>
-                </p:cTn>
-                <p:tgtEl>
-                  <p:spTgt spid="4"/>
-                </p:tgtEl>
-              </p:cMediaNode>
-            </p:video>
-          </p:childTnLst>
-        </p:cTn>
-      </p:par>
-    </p:tnLst>
-  </p:timing>
-</p:sld>
-</file>
-
-<file path=ppt/slides/slide8.xml><?xml version="1.0" encoding="utf-8"?>
-<p:sld xmlns:a="http://schemas.openxmlformats.org/drawingml/2006/main" xmlns:p="http://schemas.openxmlformats.org/presentationml/2006/main" xmlns:r="http://schemas.openxmlformats.org/officeDocument/2006/relationships">
-  <p:cSld>
-    <p:bg>
-      <p:bgPr>
-        <a:solidFill>
-          <a:srgbClr val="1A1A2E"/>
-        </a:solidFill>
-        <a:effectLst/>
-      </p:bgPr>
-    </p:bg>
-    <p:spTree>
-      <p:nvGrpSpPr>
-        <p:cNvPr id="1" name=""/>
-        <p:cNvGrpSpPr/>
-        <p:nvPr/>
-      </p:nvGrpSpPr>
-      <p:grpSpPr/>
-      <p:sp>
-        <p:nvSpPr>
-          <p:cNvPr id="2" name="TextBox 1"/>
-          <p:cNvSpPr txBox="1"/>
-          <p:nvPr/>
-        </p:nvSpPr>
-        <p:spPr>
-          <a:xfrm>
-            <a:off x="914400" y="457200"/>
+            <a:off x="914400" y="731520"/>
             <a:ext cx="10058400" cy="731520"/>
           </a:xfrm>
           <a:prstGeom prst="rect">
@@ -4148,8 +3959,8 @@
         </p:nvSpPr>
         <p:spPr>
           <a:xfrm>
-            <a:off x="2286000" y="1645920"/>
-            <a:ext cx="7315200" cy="457200"/>
+            <a:off x="1828800" y="1645920"/>
+            <a:ext cx="8229600" cy="457200"/>
           </a:xfrm>
           <a:prstGeom prst="rect">
             <a:avLst/>
@@ -4170,7 +3981,7 @@
               </a:defRPr>
             </a:pPr>
             <a:r>
-              <a:t>✓  6 大验证算例全部通过</a:t>
+              <a:t>✓ 4 大演示场景: 静力学 · 接触 · 静电 · 热-力-损伤(CDP)</a:t>
             </a:r>
           </a:p>
         </p:txBody>
@@ -4183,8 +3994,43 @@
         </p:nvSpPr>
         <p:spPr>
           <a:xfrm>
-            <a:off x="2286000" y="2286000"/>
-            <a:ext cx="7315200" cy="457200"/>
+            <a:off x="1828800" y="2240280"/>
+            <a:ext cx="8229600" cy="457200"/>
+          </a:xfrm>
+          <a:prstGeom prst="rect">
+            <a:avLst/>
+          </a:prstGeom>
+          <a:noFill/>
+        </p:spPr>
+        <p:txBody>
+          <a:bodyPr wrap="none">
+            <a:spAutoFit/>
+          </a:bodyPr>
+          <a:lstStyle/>
+          <a:p>
+            <a:pPr>
+              <a:defRPr sz="1800">
+                <a:solidFill>
+                  <a:srgbClr val="FFFFFF"/>
+                </a:solidFill>
+              </a:defRPr>
+            </a:pPr>
+            <a:r>
+              <a:t>✓ Hex8 + B-bar 单元 · Lagrange 乘子法接触约束</a:t>
+            </a:r>
+          </a:p>
+        </p:txBody>
+      </p:sp>
+      <p:sp>
+        <p:nvSpPr>
+          <p:cNvPr id="5" name="TextBox 4"/>
+          <p:cNvSpPr txBox="1"/>
+          <p:nvPr/>
+        </p:nvSpPr>
+        <p:spPr>
+          <a:xfrm>
+            <a:off x="1828800" y="2834640"/>
+            <a:ext cx="8229600" cy="457200"/>
           </a:xfrm>
           <a:prstGeom prst="rect">
             <a:avLst/>
@@ -4205,21 +4051,21 @@
               </a:defRPr>
             </a:pPr>
             <a:r>
-              <a:t>✓  网格收敛精度 0.11% (vs 理论解)</a:t>
-            </a:r>
-          </a:p>
-        </p:txBody>
-      </p:sp>
-      <p:sp>
-        <p:nvSpPr>
-          <p:cNvPr id="5" name="TextBox 4"/>
+              <a:t>✓ 温度-应力-损伤三场直接耦合 (CDP 本构)</a:t>
+            </a:r>
+          </a:p>
+        </p:txBody>
+      </p:sp>
+      <p:sp>
+        <p:nvSpPr>
+          <p:cNvPr id="6" name="TextBox 5"/>
           <p:cNvSpPr txBox="1"/>
           <p:nvPr/>
         </p:nvSpPr>
         <p:spPr>
           <a:xfrm>
-            <a:off x="2286000" y="2926080"/>
-            <a:ext cx="7315200" cy="457200"/>
+            <a:off x="1828800" y="3429000"/>
+            <a:ext cx="8229600" cy="457200"/>
           </a:xfrm>
           <a:prstGeom prst="rect">
             <a:avLst/>
@@ -4240,42 +4086,7 @@
               </a:defRPr>
             </a:pPr>
             <a:r>
-              <a:t>✓  端到端管线: Gmsh → MOOSE → ParaView</a:t>
-            </a:r>
-          </a:p>
-        </p:txBody>
-      </p:sp>
-      <p:sp>
-        <p:nvSpPr>
-          <p:cNvPr id="6" name="TextBox 5"/>
-          <p:cNvSpPr txBox="1"/>
-          <p:nvPr/>
-        </p:nvSpPr>
-        <p:spPr>
-          <a:xfrm>
-            <a:off x="2286000" y="3566159"/>
-            <a:ext cx="7315200" cy="457200"/>
-          </a:xfrm>
-          <a:prstGeom prst="rect">
-            <a:avLst/>
-          </a:prstGeom>
-          <a:noFill/>
-        </p:spPr>
-        <p:txBody>
-          <a:bodyPr wrap="none">
-            <a:spAutoFit/>
-          </a:bodyPr>
-          <a:lstStyle/>
-          <a:p>
-            <a:pPr>
-              <a:defRPr sz="1800">
-                <a:solidFill>
-                  <a:srgbClr val="D4AF37"/>
-                </a:solidFill>
-              </a:defRPr>
-            </a:pPr>
-            <a:r>
-              <a:t>✓  3 物理场直接耦合 (热+力+损伤)</a:t>
+              <a:t>✓ 网格收敛精度 0.11% (vs Euler-Bernoulli 理论解)</a:t>
             </a:r>
           </a:p>
         </p:txBody>
@@ -4288,8 +4099,8 @@
         </p:nvSpPr>
         <p:spPr>
           <a:xfrm>
-            <a:off x="2286000" y="4206240"/>
-            <a:ext cx="7315200" cy="457200"/>
+            <a:off x="1828800" y="4023360"/>
+            <a:ext cx="8229600" cy="457200"/>
           </a:xfrm>
           <a:prstGeom prst="rect">
             <a:avLst/>
@@ -4310,7 +4121,7 @@
               </a:defRPr>
             </a:pPr>
             <a:r>
-              <a:t>✓  6 个仿真动画 · 全部来自真实 FEM 数据</a:t>
+              <a:t>✓ 端到端管线: Gmsh → hongchuang-opt (MOOSE) → ParaView</a:t>
             </a:r>
           </a:p>
         </p:txBody>
@@ -4323,8 +4134,8 @@
         </p:nvSpPr>
         <p:spPr>
           <a:xfrm>
-            <a:off x="2286000" y="4846320"/>
-            <a:ext cx="7315200" cy="457200"/>
+            <a:off x="1828800" y="4617720"/>
+            <a:ext cx="8229600" cy="457200"/>
           </a:xfrm>
           <a:prstGeom prst="rect">
             <a:avLst/>
@@ -4340,12 +4151,12 @@
             <a:pPr>
               <a:defRPr sz="1800">
                 <a:solidFill>
-                  <a:srgbClr val="D4AF37"/>
+                  <a:srgbClr val="FFFFFF"/>
                 </a:solidFill>
               </a:defRPr>
             </a:pPr>
             <a:r>
-              <a:t>✓  完整投标文档: 三手册 + 架构 + 性能 + 回归</a:t>
+              <a:t>✓ 11 个 ExodusII (.e) 输出文件 · 完整文档体系</a:t>
             </a:r>
           </a:p>
         </p:txBody>

</xml_diff>